<commit_message>
System Design 101 (vi): separate destroyed sessions from refused first requests in sd-08-007
Co-Authored-By: Claude Sonnet 5.5 <noreply@anthropic.com>
Claude-Session: https://claude.ai/code/session_01DkN7YTqFfdjb8A8J5ehSWS
</commit_message>
<xml_diff>
--- a/system-design-101/vi/lessons/sd-08-007/slides/sd-08-007.pptx
+++ b/system-design-101/vi/lessons/sd-08-007/slides/sd-08-007.pptx
@@ -10001,7 +10001,62 @@
                 <a:ea typeface="Be Vietnam Pro" pitchFamily="34" charset="-122"/>
                 <a:cs typeface="Be Vietnam Pro" pitchFamily="34" charset="-120"/>
               </a:rPr>
-              <a:t> bản: 200</a:t>
+              <a:t> bản:</a:t>
+            </a:r>
+            <a:r>
+              <a:rPr lang="en-US" sz="2250" dirty="0" spc="1" kern="0">
+                <a:solidFill>
+                  <a:srgbClr val="14161C"/>
+                </a:solidFill>
+                <a:latin typeface="Be Vietnam Pro" pitchFamily="34" charset="0"/>
+                <a:ea typeface="Be Vietnam Pro" pitchFamily="34" charset="-122"/>
+                <a:cs typeface="Be Vietnam Pro" pitchFamily="34" charset="-120"/>
+              </a:rPr>
+              <a:t> 100</a:t>
+            </a:r>
+            <a:r>
+              <a:rPr lang="en-US" sz="2250" dirty="0" spc="0" kern="0">
+                <a:solidFill>
+                  <a:srgbClr val="14161C"/>
+                </a:solidFill>
+                <a:latin typeface="Be Vietnam Pro" pitchFamily="34" charset="0"/>
+                <a:ea typeface="Be Vietnam Pro" pitchFamily="34" charset="-122"/>
+                <a:cs typeface="Be Vietnam Pro" pitchFamily="34" charset="-120"/>
+              </a:rPr>
+              <a:t> phiên</a:t>
+            </a:r>
+            <a:r>
+              <a:rPr lang="en-US" sz="2250" dirty="0" spc="-13" kern="0">
+                <a:solidFill>
+                  <a:srgbClr val="14161C"/>
+                </a:solidFill>
+                <a:latin typeface="Be Vietnam Pro" pitchFamily="34" charset="0"/>
+                <a:ea typeface="Be Vietnam Pro" pitchFamily="34" charset="-122"/>
+                <a:cs typeface="Be Vietnam Pro" pitchFamily="34" charset="-120"/>
+              </a:rPr>
+              <a:t> mất</a:t>
+            </a:r>
+            <a:r>
+              <a:rPr lang="en-US" sz="2250" dirty="0" spc="-8" kern="0">
+                <a:solidFill>
+                  <a:srgbClr val="14161C"/>
+                </a:solidFill>
+                <a:latin typeface="Be Vietnam Pro" pitchFamily="34" charset="0"/>
+                <a:ea typeface="Be Vietnam Pro" pitchFamily="34" charset="-122"/>
+                <a:cs typeface="Be Vietnam Pro" pitchFamily="34" charset="-120"/>
+              </a:rPr>
+              <a:t> thật;</a:t>
+            </a:r>
+            <a:r>
+              <a:rPr lang="en-US" sz="2250" dirty="0" spc="-1" kern="0">
+                <a:solidFill>
+                  <a:srgbClr val="14161C"/>
+                </a:solidFill>
+                <a:latin typeface="Be Vietnam Pro" pitchFamily="34" charset="0"/>
+                <a:ea typeface="Be Vietnam Pro" pitchFamily="34" charset="-122"/>
+                <a:cs typeface="Be Vietnam Pro" pitchFamily="34" charset="-120"/>
+              </a:rPr>
+              <a:t> 200</a:t>
             </a:r>
             <a:r>
               <a:rPr lang="en-US" sz="2250" dirty="0" spc="-18" kern="0">
@@ -10015,7 +10070,7 @@
               <a:t> trên</a:t>
             </a:r>
             <a:r>
-              <a:rPr lang="en-US" sz="2250" dirty="0" spc="-6" kern="0">
+              <a:rPr lang="en-US" sz="2250" dirty="0" spc="-5" kern="0">
                 <a:solidFill>
                   <a:srgbClr val="14161C"/>
                 </a:solidFill>
@@ -10026,26 +10081,15 @@
               <a:t> 301</a:t>
             </a:r>
             <a:r>
-              <a:rPr lang="en-US" sz="2250" dirty="0" spc="6" kern="0">
-                <a:solidFill>
-                  <a:srgbClr val="14161C"/>
-                </a:solidFill>
-                <a:latin typeface="Be Vietnam Pro" pitchFamily="34" charset="0"/>
-                <a:ea typeface="Be Vietnam Pro" pitchFamily="34" charset="-122"/>
-                <a:cs typeface="Be Vietnam Pro" pitchFamily="34" charset="-120"/>
-              </a:rPr>
-              <a:t> người</a:t>
-            </a:r>
-            <a:r>
-              <a:rPr lang="en-US" sz="2250" dirty="0" spc="-13" kern="0">
-                <a:solidFill>
-                  <a:srgbClr val="14161C"/>
-                </a:solidFill>
-                <a:latin typeface="Be Vietnam Pro" pitchFamily="34" charset="0"/>
-                <a:ea typeface="Be Vietnam Pro" pitchFamily="34" charset="-122"/>
-                <a:cs typeface="Be Vietnam Pro" pitchFamily="34" charset="-120"/>
-              </a:rPr>
-              <a:t> mất</a:t>
+              <a:rPr lang="en-US" sz="2250" dirty="0" spc="-21" kern="0">
+                <a:solidFill>
+                  <a:srgbClr val="14161C"/>
+                </a:solidFill>
+                <a:latin typeface="Be Vietnam Pro" pitchFamily="34" charset="0"/>
+                <a:ea typeface="Be Vietnam Pro" pitchFamily="34" charset="-122"/>
+                <a:cs typeface="Be Vietnam Pro" pitchFamily="34" charset="-120"/>
+              </a:rPr>
+              <a:t> yêu</a:t>
             </a:r>
             <a:r>
               <a:rPr lang="en-US" sz="2250" dirty="0" spc="1" kern="0">
@@ -10056,7 +10100,51 @@
                 <a:ea typeface="Be Vietnam Pro" pitchFamily="34" charset="-122"/>
                 <a:cs typeface="Be Vietnam Pro" pitchFamily="34" charset="-120"/>
               </a:rPr>
-              <a:t> phiên.</a:t>
+              <a:t> cầu</a:t>
+            </a:r>
+            <a:r>
+              <a:rPr lang="en-US" sz="2250" dirty="0" spc="11" kern="0">
+                <a:solidFill>
+                  <a:srgbClr val="14161C"/>
+                </a:solidFill>
+                <a:latin typeface="Be Vietnam Pro" pitchFamily="34" charset="0"/>
+                <a:ea typeface="Be Vietnam Pro" pitchFamily="34" charset="-122"/>
+                <a:cs typeface="Be Vietnam Pro" pitchFamily="34" charset="-120"/>
+              </a:rPr>
+              <a:t> đầu</a:t>
+            </a:r>
+            <a:r>
+              <a:rPr lang="en-US" sz="2250" dirty="0" spc="2" kern="0">
+                <a:solidFill>
+                  <a:srgbClr val="14161C"/>
+                </a:solidFill>
+                <a:latin typeface="Be Vietnam Pro" pitchFamily="34" charset="0"/>
+                <a:ea typeface="Be Vietnam Pro" pitchFamily="34" charset="-122"/>
+                <a:cs typeface="Be Vietnam Pro" pitchFamily="34" charset="-120"/>
+              </a:rPr>
+              <a:t> bị</a:t>
+            </a:r>
+            <a:r>
+              <a:rPr lang="en-US" sz="2250" dirty="0" spc="3" kern="0">
+                <a:solidFill>
+                  <a:srgbClr val="14161C"/>
+                </a:solidFill>
+                <a:latin typeface="Be Vietnam Pro" pitchFamily="34" charset="0"/>
+                <a:ea typeface="Be Vietnam Pro" pitchFamily="34" charset="-122"/>
+                <a:cs typeface="Be Vietnam Pro" pitchFamily="34" charset="-120"/>
+              </a:rPr>
+              <a:t> từ</a:t>
+            </a:r>
+            <a:r>
+              <a:rPr lang="en-US" sz="2250" dirty="0" spc="2" kern="0">
+                <a:solidFill>
+                  <a:srgbClr val="14161C"/>
+                </a:solidFill>
+                <a:latin typeface="Be Vietnam Pro" pitchFamily="34" charset="0"/>
+                <a:ea typeface="Be Vietnam Pro" pitchFamily="34" charset="-122"/>
+                <a:cs typeface="Be Vietnam Pro" pitchFamily="34" charset="-120"/>
+              </a:rPr>
+              <a:t> chối.</a:t>
             </a:r>
             <a:endParaRPr lang="en-US" sz="2250" dirty="0"/>
           </a:p>
@@ -10435,26 +10523,15 @@
               <a:t> 301</a:t>
             </a:r>
             <a:r>
-              <a:rPr lang="en-US" sz="2250" dirty="0" spc="5" kern="0">
-                <a:solidFill>
-                  <a:srgbClr val="14161C"/>
-                </a:solidFill>
-                <a:latin typeface="Be Vietnam Pro" pitchFamily="34" charset="0"/>
-                <a:ea typeface="Be Vietnam Pro" pitchFamily="34" charset="-122"/>
-                <a:cs typeface="Be Vietnam Pro" pitchFamily="34" charset="-120"/>
-              </a:rPr>
-              <a:t> người</a:t>
-            </a:r>
-            <a:r>
-              <a:rPr lang="en-US" sz="2250" dirty="0" spc="-12" kern="0">
-                <a:solidFill>
-                  <a:srgbClr val="14161C"/>
-                </a:solidFill>
-                <a:latin typeface="Be Vietnam Pro" pitchFamily="34" charset="0"/>
-                <a:ea typeface="Be Vietnam Pro" pitchFamily="34" charset="-122"/>
-                <a:cs typeface="Be Vietnam Pro" pitchFamily="34" charset="-120"/>
-              </a:rPr>
-              <a:t> mất</a:t>
+              <a:rPr lang="en-US" sz="2250" dirty="0" spc="-21" kern="0">
+                <a:solidFill>
+                  <a:srgbClr val="14161C"/>
+                </a:solidFill>
+                <a:latin typeface="Be Vietnam Pro" pitchFamily="34" charset="0"/>
+                <a:ea typeface="Be Vietnam Pro" pitchFamily="34" charset="-122"/>
+                <a:cs typeface="Be Vietnam Pro" pitchFamily="34" charset="-120"/>
+              </a:rPr>
+              <a:t> yêu</a:t>
             </a:r>
             <a:r>
               <a:rPr lang="en-US" sz="2250" dirty="0" spc="1" kern="0">
@@ -10465,7 +10542,51 @@
                 <a:ea typeface="Be Vietnam Pro" pitchFamily="34" charset="-122"/>
                 <a:cs typeface="Be Vietnam Pro" pitchFamily="34" charset="-120"/>
               </a:rPr>
-              <a:t> phiên.</a:t>
+              <a:t> cầu</a:t>
+            </a:r>
+            <a:r>
+              <a:rPr lang="en-US" sz="2250" dirty="0" spc="11" kern="0">
+                <a:solidFill>
+                  <a:srgbClr val="14161C"/>
+                </a:solidFill>
+                <a:latin typeface="Be Vietnam Pro" pitchFamily="34" charset="0"/>
+                <a:ea typeface="Be Vietnam Pro" pitchFamily="34" charset="-122"/>
+                <a:cs typeface="Be Vietnam Pro" pitchFamily="34" charset="-120"/>
+              </a:rPr>
+              <a:t> đầu</a:t>
+            </a:r>
+            <a:r>
+              <a:rPr lang="en-US" sz="2250" dirty="0" spc="2" kern="0">
+                <a:solidFill>
+                  <a:srgbClr val="14161C"/>
+                </a:solidFill>
+                <a:latin typeface="Be Vietnam Pro" pitchFamily="34" charset="0"/>
+                <a:ea typeface="Be Vietnam Pro" pitchFamily="34" charset="-122"/>
+                <a:cs typeface="Be Vietnam Pro" pitchFamily="34" charset="-120"/>
+              </a:rPr>
+              <a:t> bị</a:t>
+            </a:r>
+            <a:r>
+              <a:rPr lang="en-US" sz="2250" dirty="0" spc="3" kern="0">
+                <a:solidFill>
+                  <a:srgbClr val="14161C"/>
+                </a:solidFill>
+                <a:latin typeface="Be Vietnam Pro" pitchFamily="34" charset="0"/>
+                <a:ea typeface="Be Vietnam Pro" pitchFamily="34" charset="-122"/>
+                <a:cs typeface="Be Vietnam Pro" pitchFamily="34" charset="-120"/>
+              </a:rPr>
+              <a:t> từ</a:t>
+            </a:r>
+            <a:r>
+              <a:rPr lang="en-US" sz="2250" dirty="0" spc="2" kern="0">
+                <a:solidFill>
+                  <a:srgbClr val="14161C"/>
+                </a:solidFill>
+                <a:latin typeface="Be Vietnam Pro" pitchFamily="34" charset="0"/>
+                <a:ea typeface="Be Vietnam Pro" pitchFamily="34" charset="-122"/>
+                <a:cs typeface="Be Vietnam Pro" pitchFamily="34" charset="-120"/>
+              </a:rPr>
+              <a:t> chối.</a:t>
             </a:r>
             <a:endParaRPr lang="en-US" sz="2250" dirty="0"/>
           </a:p>

</xml_diff>